<commit_message>
Implemeted updates according to changes in regulation from TCMV 30.10.2018
</commit_message>
<xml_diff>
--- a/Documentation/TUG_VECTO_Engine_Manual.pptx
+++ b/Documentation/TUG_VECTO_Engine_Manual.pptx
@@ -148,6 +148,22 @@
       </a:defRPr>
     </a:lvl9pPr>
   </p:defaultTextStyle>
+  <p:extLst>
+    <p:ext uri="{EFAFB233-063F-42B5-8137-9DF3F51BA10A}">
+      <p15:sldGuideLst xmlns:p15="http://schemas.microsoft.com/office/powerpoint/2012/main">
+        <p15:guide id="1" orient="horz" pos="2160">
+          <p15:clr>
+            <a:srgbClr val="A4A3A4"/>
+          </p15:clr>
+        </p15:guide>
+        <p15:guide id="2" pos="2880">
+          <p15:clr>
+            <a:srgbClr val="A4A3A4"/>
+          </p15:clr>
+        </p15:guide>
+      </p15:sldGuideLst>
+    </p:ext>
+  </p:extLst>
 </p:presentation>
 </file>
 
@@ -3598,238 +3614,6 @@
       </p:grpSpPr>
       <p:sp>
         <p:nvSpPr>
-          <p:cNvPr id="1026" name="Line 20"/>
-          <p:cNvSpPr>
-            <a:spLocks noChangeShapeType="1"/>
-          </p:cNvSpPr>
-          <p:nvPr/>
-        </p:nvSpPr>
-        <p:spPr bwMode="auto">
-          <a:xfrm>
-            <a:off x="0" y="415925"/>
-            <a:ext cx="9144000" cy="0"/>
-          </a:xfrm>
-          <a:prstGeom prst="line">
-            <a:avLst/>
-          </a:prstGeom>
-          <a:noFill/>
-          <a:ln w="9525">
-            <a:solidFill>
-              <a:schemeClr val="tx1"/>
-            </a:solidFill>
-            <a:round/>
-            <a:headEnd/>
-            <a:tailEnd/>
-          </a:ln>
-          <a:effectLst/>
-          <a:extLst>
-            <a:ext uri="{909E8E84-426E-40DD-AFC4-6F175D3DCCD1}">
-              <a14:hiddenFill xmlns:a14="http://schemas.microsoft.com/office/drawing/2010/main">
-                <a:noFill/>
-              </a14:hiddenFill>
-            </a:ext>
-            <a:ext uri="{AF507438-7753-43E0-B8FC-AC1667EBCBE1}">
-              <a14:hiddenEffects xmlns:a14="http://schemas.microsoft.com/office/drawing/2010/main">
-                <a:effectLst>
-                  <a:outerShdw dist="35921" dir="2700000" algn="ctr" rotWithShape="0">
-                    <a:schemeClr val="bg2"/>
-                  </a:outerShdw>
-                </a:effectLst>
-              </a14:hiddenEffects>
-            </a:ext>
-          </a:extLst>
-        </p:spPr>
-        <p:txBody>
-          <a:bodyPr/>
-          <a:lstStyle/>
-          <a:p>
-            <a:endParaRPr lang="de-AT"/>
-          </a:p>
-        </p:txBody>
-      </p:sp>
-      <p:sp>
-        <p:nvSpPr>
-          <p:cNvPr id="1027" name="Text Box 21"/>
-          <p:cNvSpPr txBox="1">
-            <a:spLocks noChangeArrowheads="1"/>
-          </p:cNvSpPr>
-          <p:nvPr/>
-        </p:nvSpPr>
-        <p:spPr bwMode="auto">
-          <a:xfrm>
-            <a:off x="781050" y="207963"/>
-            <a:ext cx="5529263" cy="215900"/>
-          </a:xfrm>
-          <a:prstGeom prst="rect">
-            <a:avLst/>
-          </a:prstGeom>
-          <a:noFill/>
-          <a:ln>
-            <a:noFill/>
-          </a:ln>
-          <a:effectLst/>
-          <a:extLst>
-            <a:ext uri="{909E8E84-426E-40DD-AFC4-6F175D3DCCD1}">
-              <a14:hiddenFill xmlns:a14="http://schemas.microsoft.com/office/drawing/2010/main">
-                <a:solidFill>
-                  <a:schemeClr val="accent1"/>
-                </a:solidFill>
-              </a14:hiddenFill>
-            </a:ext>
-            <a:ext uri="{91240B29-F687-4F45-9708-019B960494DF}">
-              <a14:hiddenLine xmlns:a14="http://schemas.microsoft.com/office/drawing/2010/main" w="9525">
-                <a:solidFill>
-                  <a:schemeClr val="tx1"/>
-                </a:solidFill>
-                <a:miter lim="800000"/>
-                <a:headEnd/>
-                <a:tailEnd/>
-              </a14:hiddenLine>
-            </a:ext>
-            <a:ext uri="{AF507438-7753-43E0-B8FC-AC1667EBCBE1}">
-              <a14:hiddenEffects xmlns:a14="http://schemas.microsoft.com/office/drawing/2010/main">
-                <a:effectLst>
-                  <a:outerShdw dist="35921" dir="2700000" algn="ctr" rotWithShape="0">
-                    <a:schemeClr val="bg2"/>
-                  </a:outerShdw>
-                </a:effectLst>
-              </a14:hiddenEffects>
-            </a:ext>
-          </a:extLst>
-        </p:spPr>
-        <p:txBody>
-          <a:bodyPr wrap="none" lIns="90000" anchor="ctr"/>
-          <a:lstStyle>
-            <a:lvl1pPr eaLnBrk="0" hangingPunct="0">
-              <a:spcBef>
-                <a:spcPct val="30000"/>
-              </a:spcBef>
-              <a:defRPr sz="2000" b="1">
-                <a:solidFill>
-                  <a:schemeClr val="tx1"/>
-                </a:solidFill>
-                <a:latin typeface="Arial" charset="0"/>
-              </a:defRPr>
-            </a:lvl1pPr>
-            <a:lvl2pPr marL="742950" indent="-285750" eaLnBrk="0" hangingPunct="0">
-              <a:spcBef>
-                <a:spcPct val="30000"/>
-              </a:spcBef>
-              <a:defRPr sz="2000" b="1">
-                <a:solidFill>
-                  <a:schemeClr val="tx1"/>
-                </a:solidFill>
-                <a:latin typeface="Arial" charset="0"/>
-              </a:defRPr>
-            </a:lvl2pPr>
-            <a:lvl3pPr marL="1143000" indent="-228600" eaLnBrk="0" hangingPunct="0">
-              <a:spcBef>
-                <a:spcPct val="30000"/>
-              </a:spcBef>
-              <a:defRPr sz="2000" b="1">
-                <a:solidFill>
-                  <a:schemeClr val="tx1"/>
-                </a:solidFill>
-                <a:latin typeface="Arial" charset="0"/>
-              </a:defRPr>
-            </a:lvl3pPr>
-            <a:lvl4pPr marL="1600200" indent="-228600" eaLnBrk="0" hangingPunct="0">
-              <a:spcBef>
-                <a:spcPct val="30000"/>
-              </a:spcBef>
-              <a:defRPr sz="2000" b="1">
-                <a:solidFill>
-                  <a:schemeClr val="tx1"/>
-                </a:solidFill>
-                <a:latin typeface="Arial" charset="0"/>
-              </a:defRPr>
-            </a:lvl4pPr>
-            <a:lvl5pPr marL="2057400" indent="-228600" eaLnBrk="0" hangingPunct="0">
-              <a:spcBef>
-                <a:spcPct val="30000"/>
-              </a:spcBef>
-              <a:defRPr sz="2000" b="1">
-                <a:solidFill>
-                  <a:schemeClr val="tx1"/>
-                </a:solidFill>
-                <a:latin typeface="Arial" charset="0"/>
-              </a:defRPr>
-            </a:lvl5pPr>
-            <a:lvl6pPr marL="2514600" indent="-228600" algn="ctr" eaLnBrk="0" fontAlgn="base" hangingPunct="0">
-              <a:spcBef>
-                <a:spcPct val="30000"/>
-              </a:spcBef>
-              <a:spcAft>
-                <a:spcPct val="0"/>
-              </a:spcAft>
-              <a:defRPr sz="2000" b="1">
-                <a:solidFill>
-                  <a:schemeClr val="tx1"/>
-                </a:solidFill>
-                <a:latin typeface="Arial" charset="0"/>
-              </a:defRPr>
-            </a:lvl6pPr>
-            <a:lvl7pPr marL="2971800" indent="-228600" algn="ctr" eaLnBrk="0" fontAlgn="base" hangingPunct="0">
-              <a:spcBef>
-                <a:spcPct val="30000"/>
-              </a:spcBef>
-              <a:spcAft>
-                <a:spcPct val="0"/>
-              </a:spcAft>
-              <a:defRPr sz="2000" b="1">
-                <a:solidFill>
-                  <a:schemeClr val="tx1"/>
-                </a:solidFill>
-                <a:latin typeface="Arial" charset="0"/>
-              </a:defRPr>
-            </a:lvl7pPr>
-            <a:lvl8pPr marL="3429000" indent="-228600" algn="ctr" eaLnBrk="0" fontAlgn="base" hangingPunct="0">
-              <a:spcBef>
-                <a:spcPct val="30000"/>
-              </a:spcBef>
-              <a:spcAft>
-                <a:spcPct val="0"/>
-              </a:spcAft>
-              <a:defRPr sz="2000" b="1">
-                <a:solidFill>
-                  <a:schemeClr val="tx1"/>
-                </a:solidFill>
-                <a:latin typeface="Arial" charset="0"/>
-              </a:defRPr>
-            </a:lvl8pPr>
-            <a:lvl9pPr marL="3886200" indent="-228600" algn="ctr" eaLnBrk="0" fontAlgn="base" hangingPunct="0">
-              <a:spcBef>
-                <a:spcPct val="30000"/>
-              </a:spcBef>
-              <a:spcAft>
-                <a:spcPct val="0"/>
-              </a:spcAft>
-              <a:defRPr sz="2000" b="1">
-                <a:solidFill>
-                  <a:schemeClr val="tx1"/>
-                </a:solidFill>
-                <a:latin typeface="Arial" charset="0"/>
-              </a:defRPr>
-            </a:lvl9pPr>
-          </a:lstStyle>
-          <a:p>
-            <a:pPr algn="l" eaLnBrk="1" hangingPunct="1">
-              <a:spcBef>
-                <a:spcPct val="50000"/>
-              </a:spcBef>
-              <a:defRPr/>
-            </a:pPr>
-            <a:r>
-              <a:rPr lang="en-US" sz="1000" smtClean="0">
-                <a:latin typeface="Verdana" pitchFamily="34" charset="0"/>
-              </a:rPr>
-              <a:t>Institute of Internal Combustion Engines and Thermodynamics</a:t>
-            </a:r>
-          </a:p>
-        </p:txBody>
-      </p:sp>
-      <p:sp>
-        <p:nvSpPr>
           <p:cNvPr id="1028" name="Rectangle 22"/>
           <p:cNvSpPr>
             <a:spLocks noGrp="1" noChangeArrowheads="1"/>
@@ -4207,9 +3991,7 @@
             <a:srgbClr val="DDDDDD"/>
           </a:solidFill>
           <a:ln w="6350">
-            <a:solidFill>
-              <a:schemeClr val="tx1"/>
-            </a:solidFill>
+            <a:noFill/>
             <a:miter lim="800000"/>
             <a:headEnd/>
             <a:tailEnd/>
@@ -4239,172 +4021,6 @@
             <a:endParaRPr lang="en-GB" sz="1200">
               <a:latin typeface="Verdana" pitchFamily="34" charset="0"/>
             </a:endParaRPr>
-          </a:p>
-        </p:txBody>
-      </p:sp>
-      <p:pic>
-        <p:nvPicPr>
-          <p:cNvPr id="1032" name="Picture 26" descr="logo"/>
-          <p:cNvPicPr>
-            <a:picLocks noChangeAspect="1" noChangeArrowheads="1"/>
-          </p:cNvPicPr>
-          <p:nvPr/>
-        </p:nvPicPr>
-        <p:blipFill>
-          <a:blip r:embed="rId15" cstate="print">
-            <a:extLst>
-              <a:ext uri="{28A0092B-C50C-407E-A947-70E740481C1C}">
-                <a14:useLocalDpi xmlns:a14="http://schemas.microsoft.com/office/drawing/2010/main" val="0"/>
-              </a:ext>
-            </a:extLst>
-          </a:blip>
-          <a:srcRect/>
-          <a:stretch>
-            <a:fillRect/>
-          </a:stretch>
-        </p:blipFill>
-        <p:spPr bwMode="auto">
-          <a:xfrm>
-            <a:off x="7947025" y="50800"/>
-            <a:ext cx="868363" cy="319088"/>
-          </a:xfrm>
-          <a:prstGeom prst="rect">
-            <a:avLst/>
-          </a:prstGeom>
-          <a:noFill/>
-          <a:ln>
-            <a:noFill/>
-          </a:ln>
-          <a:extLst>
-            <a:ext uri="{909E8E84-426E-40DD-AFC4-6F175D3DCCD1}">
-              <a14:hiddenFill xmlns:a14="http://schemas.microsoft.com/office/drawing/2010/main">
-                <a:solidFill>
-                  <a:srgbClr val="FFFFFF"/>
-                </a:solidFill>
-              </a14:hiddenFill>
-            </a:ext>
-            <a:ext uri="{91240B29-F687-4F45-9708-019B960494DF}">
-              <a14:hiddenLine xmlns:a14="http://schemas.microsoft.com/office/drawing/2010/main" w="9525">
-                <a:solidFill>
-                  <a:srgbClr val="000000"/>
-                </a:solidFill>
-                <a:miter lim="800000"/>
-                <a:headEnd/>
-                <a:tailEnd/>
-              </a14:hiddenLine>
-            </a:ext>
-          </a:extLst>
-        </p:spPr>
-      </p:pic>
-      <p:pic>
-        <p:nvPicPr>
-          <p:cNvPr id="1033" name="Picture 27" descr="IVT_Logo_klein"/>
-          <p:cNvPicPr>
-            <a:picLocks noChangeAspect="1" noChangeArrowheads="1"/>
-          </p:cNvPicPr>
-          <p:nvPr/>
-        </p:nvPicPr>
-        <p:blipFill>
-          <a:blip r:embed="rId16">
-            <a:extLst>
-              <a:ext uri="{28A0092B-C50C-407E-A947-70E740481C1C}">
-                <a14:useLocalDpi xmlns:a14="http://schemas.microsoft.com/office/drawing/2010/main" val="0"/>
-              </a:ext>
-            </a:extLst>
-          </a:blip>
-          <a:srcRect/>
-          <a:stretch>
-            <a:fillRect/>
-          </a:stretch>
-        </p:blipFill>
-        <p:spPr bwMode="auto">
-          <a:xfrm>
-            <a:off x="368300" y="149225"/>
-            <a:ext cx="449263" cy="215900"/>
-          </a:xfrm>
-          <a:prstGeom prst="rect">
-            <a:avLst/>
-          </a:prstGeom>
-          <a:noFill/>
-          <a:ln>
-            <a:noFill/>
-          </a:ln>
-          <a:extLst>
-            <a:ext uri="{909E8E84-426E-40DD-AFC4-6F175D3DCCD1}">
-              <a14:hiddenFill xmlns:a14="http://schemas.microsoft.com/office/drawing/2010/main">
-                <a:solidFill>
-                  <a:srgbClr val="FFFFFF"/>
-                </a:solidFill>
-              </a14:hiddenFill>
-            </a:ext>
-            <a:ext uri="{91240B29-F687-4F45-9708-019B960494DF}">
-              <a14:hiddenLine xmlns:a14="http://schemas.microsoft.com/office/drawing/2010/main" w="9525">
-                <a:solidFill>
-                  <a:srgbClr val="000000"/>
-                </a:solidFill>
-                <a:miter lim="800000"/>
-                <a:headEnd/>
-                <a:tailEnd/>
-              </a14:hiddenLine>
-            </a:ext>
-          </a:extLst>
-        </p:spPr>
-      </p:pic>
-      <p:sp>
-        <p:nvSpPr>
-          <p:cNvPr id="1035" name="Rectangle 29"/>
-          <p:cNvSpPr>
-            <a:spLocks noChangeAspect="1" noChangeArrowheads="1"/>
-          </p:cNvSpPr>
-          <p:nvPr/>
-        </p:nvSpPr>
-        <p:spPr bwMode="auto">
-          <a:xfrm>
-            <a:off x="0" y="6373813"/>
-            <a:ext cx="215900" cy="214312"/>
-          </a:xfrm>
-          <a:prstGeom prst="rect">
-            <a:avLst/>
-          </a:prstGeom>
-          <a:solidFill>
-            <a:srgbClr val="F70146"/>
-          </a:solidFill>
-          <a:ln>
-            <a:noFill/>
-          </a:ln>
-          <a:effectLst/>
-          <a:extLst>
-            <a:ext uri="{91240B29-F687-4F45-9708-019B960494DF}">
-              <a14:hiddenLine xmlns:a14="http://schemas.microsoft.com/office/drawing/2010/main" w="9525">
-                <a:solidFill>
-                  <a:schemeClr val="tx1"/>
-                </a:solidFill>
-                <a:miter lim="800000"/>
-                <a:headEnd/>
-                <a:tailEnd/>
-              </a14:hiddenLine>
-            </a:ext>
-            <a:ext uri="{AF507438-7753-43E0-B8FC-AC1667EBCBE1}">
-              <a14:hiddenEffects xmlns:a14="http://schemas.microsoft.com/office/drawing/2010/main">
-                <a:effectLst>
-                  <a:outerShdw dist="35921" dir="2700000" algn="ctr" rotWithShape="0">
-                    <a:schemeClr val="bg2"/>
-                  </a:outerShdw>
-                </a:effectLst>
-              </a14:hiddenEffects>
-            </a:ext>
-          </a:extLst>
-        </p:spPr>
-        <p:txBody>
-          <a:bodyPr wrap="none" anchor="ctr"/>
-          <a:lstStyle/>
-          <a:p>
-            <a:pPr>
-              <a:spcBef>
-                <a:spcPct val="30000"/>
-              </a:spcBef>
-            </a:pPr>
-            <a:endParaRPr lang="en-GB" sz="2000"/>
           </a:p>
         </p:txBody>
       </p:sp>
@@ -4601,187 +4217,36 @@
           </a:p>
         </p:txBody>
       </p:sp>
-      <p:sp>
-        <p:nvSpPr>
-          <p:cNvPr id="1038" name="Text Box 32"/>
-          <p:cNvSpPr txBox="1">
-            <a:spLocks noChangeArrowheads="1"/>
-          </p:cNvSpPr>
-          <p:nvPr/>
-        </p:nvSpPr>
-        <p:spPr bwMode="auto">
+      <p:pic>
+        <p:nvPicPr>
+          <p:cNvPr id="3" name="Grafik 2"/>
+          <p:cNvPicPr>
+            <a:picLocks noChangeAspect="1"/>
+          </p:cNvPicPr>
+          <p:nvPr userDrawn="1"/>
+        </p:nvPicPr>
+        <p:blipFill>
+          <a:blip r:embed="rId15">
+            <a:extLst>
+              <a:ext uri="{28A0092B-C50C-407E-A947-70E740481C1C}">
+                <a14:useLocalDpi xmlns:a14="http://schemas.microsoft.com/office/drawing/2010/main" val="0"/>
+              </a:ext>
+            </a:extLst>
+          </a:blip>
+          <a:stretch>
+            <a:fillRect/>
+          </a:stretch>
+        </p:blipFill>
+        <p:spPr>
           <a:xfrm>
-            <a:off x="266700" y="6383338"/>
-            <a:ext cx="2936875" cy="215900"/>
+            <a:off x="7164288" y="89807"/>
+            <a:ext cx="1979712" cy="491636"/>
           </a:xfrm>
           <a:prstGeom prst="rect">
             <a:avLst/>
           </a:prstGeom>
-          <a:noFill/>
-          <a:ln>
-            <a:noFill/>
-          </a:ln>
-          <a:effectLst/>
-          <a:extLst>
-            <a:ext uri="{909E8E84-426E-40DD-AFC4-6F175D3DCCD1}">
-              <a14:hiddenFill xmlns:a14="http://schemas.microsoft.com/office/drawing/2010/main">
-                <a:solidFill>
-                  <a:schemeClr val="accent1"/>
-                </a:solidFill>
-              </a14:hiddenFill>
-            </a:ext>
-            <a:ext uri="{91240B29-F687-4F45-9708-019B960494DF}">
-              <a14:hiddenLine xmlns:a14="http://schemas.microsoft.com/office/drawing/2010/main" w="9525">
-                <a:solidFill>
-                  <a:schemeClr val="tx1"/>
-                </a:solidFill>
-                <a:miter lim="800000"/>
-                <a:headEnd/>
-                <a:tailEnd/>
-              </a14:hiddenLine>
-            </a:ext>
-            <a:ext uri="{AF507438-7753-43E0-B8FC-AC1667EBCBE1}">
-              <a14:hiddenEffects xmlns:a14="http://schemas.microsoft.com/office/drawing/2010/main">
-                <a:effectLst>
-                  <a:outerShdw dist="35921" dir="2700000" algn="ctr" rotWithShape="0">
-                    <a:schemeClr val="bg2"/>
-                  </a:outerShdw>
-                </a:effectLst>
-              </a14:hiddenEffects>
-            </a:ext>
-          </a:extLst>
         </p:spPr>
-        <p:txBody>
-          <a:bodyPr wrap="none" tIns="39600" anchor="ctr"/>
-          <a:lstStyle>
-            <a:lvl1pPr eaLnBrk="0" hangingPunct="0">
-              <a:spcBef>
-                <a:spcPct val="30000"/>
-              </a:spcBef>
-              <a:defRPr sz="2000" b="1">
-                <a:solidFill>
-                  <a:schemeClr val="tx1"/>
-                </a:solidFill>
-                <a:latin typeface="Arial" charset="0"/>
-              </a:defRPr>
-            </a:lvl1pPr>
-            <a:lvl2pPr marL="742950" indent="-285750" eaLnBrk="0" hangingPunct="0">
-              <a:spcBef>
-                <a:spcPct val="30000"/>
-              </a:spcBef>
-              <a:defRPr sz="2000" b="1">
-                <a:solidFill>
-                  <a:schemeClr val="tx1"/>
-                </a:solidFill>
-                <a:latin typeface="Arial" charset="0"/>
-              </a:defRPr>
-            </a:lvl2pPr>
-            <a:lvl3pPr marL="1143000" indent="-228600" eaLnBrk="0" hangingPunct="0">
-              <a:spcBef>
-                <a:spcPct val="30000"/>
-              </a:spcBef>
-              <a:defRPr sz="2000" b="1">
-                <a:solidFill>
-                  <a:schemeClr val="tx1"/>
-                </a:solidFill>
-                <a:latin typeface="Arial" charset="0"/>
-              </a:defRPr>
-            </a:lvl3pPr>
-            <a:lvl4pPr marL="1600200" indent="-228600" eaLnBrk="0" hangingPunct="0">
-              <a:spcBef>
-                <a:spcPct val="30000"/>
-              </a:spcBef>
-              <a:defRPr sz="2000" b="1">
-                <a:solidFill>
-                  <a:schemeClr val="tx1"/>
-                </a:solidFill>
-                <a:latin typeface="Arial" charset="0"/>
-              </a:defRPr>
-            </a:lvl4pPr>
-            <a:lvl5pPr marL="2057400" indent="-228600" eaLnBrk="0" hangingPunct="0">
-              <a:spcBef>
-                <a:spcPct val="30000"/>
-              </a:spcBef>
-              <a:defRPr sz="2000" b="1">
-                <a:solidFill>
-                  <a:schemeClr val="tx1"/>
-                </a:solidFill>
-                <a:latin typeface="Arial" charset="0"/>
-              </a:defRPr>
-            </a:lvl5pPr>
-            <a:lvl6pPr marL="2514600" indent="-228600" algn="ctr" eaLnBrk="0" fontAlgn="base" hangingPunct="0">
-              <a:spcBef>
-                <a:spcPct val="30000"/>
-              </a:spcBef>
-              <a:spcAft>
-                <a:spcPct val="0"/>
-              </a:spcAft>
-              <a:defRPr sz="2000" b="1">
-                <a:solidFill>
-                  <a:schemeClr val="tx1"/>
-                </a:solidFill>
-                <a:latin typeface="Arial" charset="0"/>
-              </a:defRPr>
-            </a:lvl6pPr>
-            <a:lvl7pPr marL="2971800" indent="-228600" algn="ctr" eaLnBrk="0" fontAlgn="base" hangingPunct="0">
-              <a:spcBef>
-                <a:spcPct val="30000"/>
-              </a:spcBef>
-              <a:spcAft>
-                <a:spcPct val="0"/>
-              </a:spcAft>
-              <a:defRPr sz="2000" b="1">
-                <a:solidFill>
-                  <a:schemeClr val="tx1"/>
-                </a:solidFill>
-                <a:latin typeface="Arial" charset="0"/>
-              </a:defRPr>
-            </a:lvl7pPr>
-            <a:lvl8pPr marL="3429000" indent="-228600" algn="ctr" eaLnBrk="0" fontAlgn="base" hangingPunct="0">
-              <a:spcBef>
-                <a:spcPct val="30000"/>
-              </a:spcBef>
-              <a:spcAft>
-                <a:spcPct val="0"/>
-              </a:spcAft>
-              <a:defRPr sz="2000" b="1">
-                <a:solidFill>
-                  <a:schemeClr val="tx1"/>
-                </a:solidFill>
-                <a:latin typeface="Arial" charset="0"/>
-              </a:defRPr>
-            </a:lvl8pPr>
-            <a:lvl9pPr marL="3886200" indent="-228600" algn="ctr" eaLnBrk="0" fontAlgn="base" hangingPunct="0">
-              <a:spcBef>
-                <a:spcPct val="30000"/>
-              </a:spcBef>
-              <a:spcAft>
-                <a:spcPct val="0"/>
-              </a:spcAft>
-              <a:defRPr sz="2000" b="1">
-                <a:solidFill>
-                  <a:schemeClr val="tx1"/>
-                </a:solidFill>
-                <a:latin typeface="Arial" charset="0"/>
-              </a:defRPr>
-            </a:lvl9pPr>
-          </a:lstStyle>
-          <a:p>
-            <a:pPr algn="l" eaLnBrk="1" hangingPunct="1">
-              <a:spcBef>
-                <a:spcPct val="0"/>
-              </a:spcBef>
-              <a:defRPr/>
-            </a:pPr>
-            <a:r>
-              <a:rPr lang="en-GB" sz="1100" b="0" dirty="0" smtClean="0">
-                <a:latin typeface="Verdana" pitchFamily="34" charset="0"/>
-              </a:rPr>
-              <a:t>IVT-EM</a:t>
-            </a:r>
-          </a:p>
-        </p:txBody>
-      </p:sp>
+      </p:pic>
     </p:spTree>
   </p:cSld>
   <p:clrMap bg1="lt1" tx1="dk1" bg2="lt2" tx2="dk2" accent1="accent1" accent2="accent2" accent3="accent3" accent4="accent4" accent5="accent5" accent6="accent6" hlink="hlink" folHlink="folHlink"/>
@@ -5233,11 +4698,7 @@
             </a:r>
             <a:r>
               <a:rPr lang="en-US" sz="2800" smtClean="0"/>
-              <a:t>user </a:t>
-            </a:r>
-            <a:r>
-              <a:rPr lang="en-US" sz="2800" smtClean="0"/>
-              <a:t>manual</a:t>
+              <a:t>user manual</a:t>
             </a:r>
             <a:endParaRPr lang="en-US" sz="2800" dirty="0"/>
           </a:p>
@@ -5276,8 +4737,17 @@
               <a:rPr lang="en-US" sz="2400" dirty="0" smtClean="0">
                 <a:sym typeface="Wingdings" panose="05000000000000000000" pitchFamily="2" charset="2"/>
               </a:rPr>
-              <a:t>App Version 1.4</a:t>
-            </a:r>
+              <a:t>App Version </a:t>
+            </a:r>
+            <a:r>
+              <a:rPr lang="en-US" sz="2400" dirty="0" smtClean="0">
+                <a:sym typeface="Wingdings" panose="05000000000000000000" pitchFamily="2" charset="2"/>
+              </a:rPr>
+              <a:t>1.4.4</a:t>
+            </a:r>
+            <a:endParaRPr lang="en-US" sz="2400" dirty="0" smtClean="0">
+              <a:sym typeface="Wingdings" panose="05000000000000000000" pitchFamily="2" charset="2"/>
+            </a:endParaRPr>
           </a:p>
           <a:p>
             <a:pPr>
@@ -5289,10 +4759,10 @@
               </a:spcAft>
             </a:pPr>
             <a:r>
-              <a:rPr lang="en-US" sz="1800" smtClean="0">
-                <a:sym typeface="Wingdings" panose="05000000000000000000" pitchFamily="2" charset="2"/>
-              </a:rPr>
-              <a:t>10.08.2017</a:t>
+              <a:rPr lang="en-US" sz="1800" dirty="0" smtClean="0">
+                <a:sym typeface="Wingdings" panose="05000000000000000000" pitchFamily="2" charset="2"/>
+              </a:rPr>
+              <a:t>20.12.2018</a:t>
             </a:r>
             <a:endParaRPr lang="en-US" sz="1800" dirty="0" smtClean="0">
               <a:sym typeface="Wingdings" panose="05000000000000000000" pitchFamily="2" charset="2"/>

</xml_diff>

<commit_message>
Update of user manual
</commit_message>
<xml_diff>
--- a/Documentation/TUG_VECTO_Engine_Manual.pptx
+++ b/Documentation/TUG_VECTO_Engine_Manual.pptx
@@ -4855,8 +4855,11 @@
               <a:rPr lang="en-US" sz="1800" dirty="0" smtClean="0">
                 <a:sym typeface="Wingdings" panose="05000000000000000000" pitchFamily="2" charset="2"/>
               </a:rPr>
-              <a:t>17.12.2019</a:t>
-            </a:r>
+              <a:t>01.06.2022</a:t>
+            </a:r>
+            <a:endParaRPr lang="en-US" sz="1800" dirty="0" smtClean="0">
+              <a:sym typeface="Wingdings" panose="05000000000000000000" pitchFamily="2" charset="2"/>
+            </a:endParaRPr>
           </a:p>
         </p:txBody>
       </p:sp>
@@ -5081,7 +5084,7 @@
                 <a:latin typeface="Helvetica" panose="020B0604020202020204" pitchFamily="34" charset="0"/>
                 <a:cs typeface="Helvetica" panose="020B0604020202020204" pitchFamily="34" charset="0"/>
               </a:rPr>
-              <a:t>https://</a:t>
+              <a:t>https</a:t>
             </a:r>
             <a:r>
               <a:rPr lang="en-US" sz="1600" u="sng" dirty="0" smtClean="0">
@@ -5091,8 +5094,15 @@
                 <a:latin typeface="Helvetica" panose="020B0604020202020204" pitchFamily="34" charset="0"/>
                 <a:cs typeface="Helvetica" panose="020B0604020202020204" pitchFamily="34" charset="0"/>
               </a:rPr>
-              <a:t>webgate.ec.europa.eu/CITnet/jira/projects/VECTO/issues</a:t>
-            </a:r>
+              <a:t>://citnet.tech.ec.europa.eu/CITnet/jira/projects/VECTO/issues</a:t>
+            </a:r>
+            <a:endParaRPr lang="en-US" sz="1600" u="sng" dirty="0" smtClean="0">
+              <a:solidFill>
+                <a:srgbClr val="00B0F0"/>
+              </a:solidFill>
+              <a:latin typeface="Helvetica" panose="020B0604020202020204" pitchFamily="34" charset="0"/>
+              <a:cs typeface="Helvetica" panose="020B0604020202020204" pitchFamily="34" charset="0"/>
+            </a:endParaRPr>
           </a:p>
           <a:p>
             <a:pPr>
@@ -5140,24 +5150,14 @@
               <a:t>https</a:t>
             </a:r>
             <a:r>
-              <a:rPr lang="en-US" sz="1400" u="sng" dirty="0">
+              <a:rPr lang="en-US" sz="1400" u="sng" dirty="0" smtClean="0">
                 <a:solidFill>
                   <a:srgbClr val="00B0F0"/>
                 </a:solidFill>
                 <a:latin typeface="Helvetica" panose="020B0604020202020204" pitchFamily="34" charset="0"/>
                 <a:cs typeface="Helvetica" panose="020B0604020202020204" pitchFamily="34" charset="0"/>
               </a:rPr>
-              <a:t>://</a:t>
-            </a:r>
-            <a:r>
-              <a:rPr lang="en-US" sz="1400" u="sng" dirty="0" smtClean="0">
-                <a:solidFill>
-                  <a:srgbClr val="00B0F0"/>
-                </a:solidFill>
-                <a:latin typeface="Helvetica" panose="020B0604020202020204" pitchFamily="34" charset="0"/>
-                <a:cs typeface="Helvetica" panose="020B0604020202020204" pitchFamily="34" charset="0"/>
-              </a:rPr>
-              <a:t>webgate.ec.europa.eu/CITnet/confluence/display/VECTO/VECTO+Engine+Releases</a:t>
+              <a:t>://citnet.tech.ec.europa.eu/CITnet/confluence/display/VECTO/VECTO+Engine+Releases</a:t>
             </a:r>
             <a:endParaRPr lang="en-US" sz="1400" dirty="0" smtClean="0">
               <a:solidFill>

</xml_diff>